<commit_message>
Add rehearsal harness, backup demo video, and live-demo deck slide
Presentation-preparedness round: scripts/rehearse_demo.py measures the
narrated timeline (benign 0.12 -> alert at ~33s -> lateral movement at
~63s, verified through the dashboard UI path); make_backup_demo.py
renders the same beats into deliverables/backup_demo/ (frames + animated
GIF) as a fallback if live infra fails; build_deck.py gains slide 7
embedding those frames with measured timings. Also: Dockerfile for
containerized demo, trust-ledger registration for run_forecast, and
gitignore for live runtime data. 111 tests pass.
</commit_message>
<xml_diff>
--- a/deliverables/Trajectory_SIH26153_Idea_Deck.pptx
+++ b/deliverables/Trajectory_SIH26153_Idea_Deck.pptx
@@ -11,6 +11,7 @@
     <p:sldId id="259" r:id="rId10"/>
     <p:sldId id="260" r:id="rId11"/>
     <p:sldId id="261" r:id="rId12"/>
+    <p:sldId id="262" r:id="rId13"/>
   </p:sldIdLst>
   <p:sldSz cx="12191695" cy="6858000" type="screen4x3"/>
   <p:notesSz cx="6858000" cy="9144000"/>
@@ -15338,6 +15339,724 @@
 </p:sld>
 </file>
 
+<file path=ppt/slides/slide7.xml><?xml version="1.0" encoding="utf-8"?>
+<p:sld xmlns:a="http://schemas.openxmlformats.org/drawingml/2006/main" xmlns:p="http://schemas.openxmlformats.org/presentationml/2006/main" xmlns:r="http://schemas.openxmlformats.org/officeDocument/2006/relationships">
+  <p:cSld>
+    <p:bg>
+      <p:bgPr>
+        <a:solidFill>
+          <a:srgbClr val="0B1220"/>
+        </a:solidFill>
+        <a:effectLst/>
+      </p:bgPr>
+    </p:bg>
+    <p:spTree>
+      <p:nvGrpSpPr>
+        <p:cNvPr id="1" name=""/>
+        <p:cNvGrpSpPr/>
+        <p:nvPr/>
+      </p:nvGrpSpPr>
+      <p:grpSpPr/>
+      <p:sp>
+        <p:nvSpPr>
+          <p:cNvPr id="2" name="Rectangle 1"/>
+          <p:cNvSpPr/>
+          <p:nvPr/>
+        </p:nvSpPr>
+        <p:spPr>
+          <a:xfrm>
+            <a:off x="0" y="0"/>
+            <a:ext cx="12191695" cy="73152"/>
+          </a:xfrm>
+          <a:prstGeom prst="rect">
+            <a:avLst/>
+          </a:prstGeom>
+          <a:solidFill>
+            <a:srgbClr val="2ED3B7"/>
+          </a:solidFill>
+          <a:ln>
+            <a:noFill/>
+          </a:ln>
+          <a:effectLst/>
+        </p:spPr>
+        <p:style>
+          <a:lnRef idx="1">
+            <a:schemeClr val="accent1"/>
+          </a:lnRef>
+          <a:fillRef idx="3">
+            <a:schemeClr val="accent1"/>
+          </a:fillRef>
+          <a:effectRef idx="2">
+            <a:schemeClr val="accent1"/>
+          </a:effectRef>
+          <a:fontRef idx="minor">
+            <a:schemeClr val="lt1"/>
+          </a:fontRef>
+        </p:style>
+        <p:txBody>
+          <a:bodyPr rtlCol="0" anchor="ctr"/>
+          <a:lstStyle/>
+          <a:p>
+            <a:pPr algn="ctr"/>
+          </a:p>
+        </p:txBody>
+      </p:sp>
+      <p:sp>
+        <p:nvSpPr>
+          <p:cNvPr id="3" name="TextBox 2"/>
+          <p:cNvSpPr txBox="1"/>
+          <p:nvPr/>
+        </p:nvSpPr>
+        <p:spPr>
+          <a:xfrm>
+            <a:off x="411480" y="164592"/>
+            <a:ext cx="9601200" cy="548640"/>
+          </a:xfrm>
+          <a:prstGeom prst="rect">
+            <a:avLst/>
+          </a:prstGeom>
+          <a:noFill/>
+        </p:spPr>
+        <p:txBody>
+          <a:bodyPr wrap="square" anchor="t" lIns="73152" rIns="73152" tIns="36576" bIns="36576">
+            <a:spAutoFit/>
+          </a:bodyPr>
+          <a:lstStyle/>
+          <a:p>
+            <a:pPr algn="l">
+              <a:lnSpc>
+                <a:spcPct val="105000"/>
+              </a:lnSpc>
+              <a:spcAft>
+                <a:spcPts val="200"/>
+              </a:spcAft>
+            </a:pPr>
+            <a:r>
+              <a:rPr sz="2600" b="1">
+                <a:solidFill>
+                  <a:srgbClr val="EEF2F8"/>
+                </a:solidFill>
+                <a:latin typeface="Calibri"/>
+              </a:rPr>
+              <a:t>Live Demo — Watch the AI Detect an Attack</a:t>
+            </a:r>
+          </a:p>
+        </p:txBody>
+      </p:sp>
+      <p:sp>
+        <p:nvSpPr>
+          <p:cNvPr id="4" name="TextBox 3"/>
+          <p:cNvSpPr txBox="1"/>
+          <p:nvPr/>
+        </p:nvSpPr>
+        <p:spPr>
+          <a:xfrm>
+            <a:off x="411480" y="658368"/>
+            <a:ext cx="10058400" cy="365760"/>
+          </a:xfrm>
+          <a:prstGeom prst="rect">
+            <a:avLst/>
+          </a:prstGeom>
+          <a:noFill/>
+        </p:spPr>
+        <p:txBody>
+          <a:bodyPr wrap="square" anchor="t" lIns="73152" rIns="73152" tIns="36576" bIns="36576">
+            <a:spAutoFit/>
+          </a:bodyPr>
+          <a:lstStyle/>
+          <a:p>
+            <a:pPr algn="l">
+              <a:lnSpc>
+                <a:spcPct val="105000"/>
+              </a:lnSpc>
+              <a:spcAft>
+                <a:spcPts val="200"/>
+              </a:spcAft>
+            </a:pPr>
+            <a:r>
+              <a:rPr sz="1300" b="0">
+                <a:solidFill>
+                  <a:srgbClr val="9FACC2"/>
+                </a:solidFill>
+                <a:latin typeface="Calibri"/>
+              </a:rPr>
+              <a:t>Real-time detection on a localhost attack simulation; deterministic and rehearsed</a:t>
+            </a:r>
+          </a:p>
+        </p:txBody>
+      </p:sp>
+      <p:sp>
+        <p:nvSpPr>
+          <p:cNvPr id="5" name="TextBox 4"/>
+          <p:cNvSpPr txBox="1"/>
+          <p:nvPr/>
+        </p:nvSpPr>
+        <p:spPr>
+          <a:xfrm>
+            <a:off x="9265615" y="182880"/>
+            <a:ext cx="2560320" cy="365760"/>
+          </a:xfrm>
+          <a:prstGeom prst="rect">
+            <a:avLst/>
+          </a:prstGeom>
+          <a:noFill/>
+        </p:spPr>
+        <p:txBody>
+          <a:bodyPr wrap="square" anchor="t" lIns="73152" rIns="73152" tIns="36576" bIns="36576">
+            <a:spAutoFit/>
+          </a:bodyPr>
+          <a:lstStyle/>
+          <a:p>
+            <a:pPr algn="r">
+              <a:lnSpc>
+                <a:spcPct val="105000"/>
+              </a:lnSpc>
+              <a:spcAft>
+                <a:spcPts val="200"/>
+              </a:spcAft>
+            </a:pPr>
+            <a:r>
+              <a:rPr sz="1000" b="0">
+                <a:solidFill>
+                  <a:srgbClr val="9FACC2"/>
+                </a:solidFill>
+                <a:latin typeface="Calibri"/>
+              </a:rPr>
+              <a:t>TRAJECTORY  |  SIH26153  |  7/6</a:t>
+            </a:r>
+          </a:p>
+        </p:txBody>
+      </p:sp>
+      <p:sp>
+        <p:nvSpPr>
+          <p:cNvPr id="6" name="Rounded Rectangle 5"/>
+          <p:cNvSpPr/>
+          <p:nvPr/>
+        </p:nvSpPr>
+        <p:spPr>
+          <a:xfrm>
+            <a:off x="411480" y="1097280"/>
+            <a:ext cx="5394960" cy="4206240"/>
+          </a:xfrm>
+          <a:prstGeom prst="roundRect">
+            <a:avLst>
+              <a:gd name="adj" fmla="val 6000"/>
+            </a:avLst>
+          </a:prstGeom>
+          <a:solidFill>
+            <a:srgbClr val="141E33"/>
+          </a:solidFill>
+          <a:ln>
+            <a:noFill/>
+          </a:ln>
+          <a:effectLst/>
+        </p:spPr>
+        <p:style>
+          <a:lnRef idx="1">
+            <a:schemeClr val="accent1"/>
+          </a:lnRef>
+          <a:fillRef idx="3">
+            <a:schemeClr val="accent1"/>
+          </a:fillRef>
+          <a:effectRef idx="2">
+            <a:schemeClr val="accent1"/>
+          </a:effectRef>
+          <a:fontRef idx="minor">
+            <a:schemeClr val="lt1"/>
+          </a:fontRef>
+        </p:style>
+        <p:txBody>
+          <a:bodyPr rtlCol="0" anchor="ctr"/>
+          <a:lstStyle/>
+          <a:p>
+            <a:pPr algn="ctr"/>
+          </a:p>
+        </p:txBody>
+      </p:sp>
+      <p:sp>
+        <p:nvSpPr>
+          <p:cNvPr id="7" name="TextBox 6"/>
+          <p:cNvSpPr txBox="1"/>
+          <p:nvPr/>
+        </p:nvSpPr>
+        <p:spPr>
+          <a:xfrm>
+            <a:off x="502920" y="1170432"/>
+            <a:ext cx="5212080" cy="365760"/>
+          </a:xfrm>
+          <a:prstGeom prst="rect">
+            <a:avLst/>
+          </a:prstGeom>
+          <a:noFill/>
+        </p:spPr>
+        <p:txBody>
+          <a:bodyPr wrap="square" anchor="t" lIns="73152" rIns="73152" tIns="36576" bIns="36576">
+            <a:spAutoFit/>
+          </a:bodyPr>
+          <a:lstStyle/>
+          <a:p>
+            <a:pPr algn="l">
+              <a:lnSpc>
+                <a:spcPct val="105000"/>
+              </a:lnSpc>
+              <a:spcAft>
+                <a:spcPts val="200"/>
+              </a:spcAft>
+            </a:pPr>
+            <a:r>
+              <a:rPr sz="1300" b="1">
+                <a:solidFill>
+                  <a:srgbClr val="2ED3B7"/>
+                </a:solidFill>
+                <a:latin typeface="Calibri"/>
+              </a:rPr>
+              <a:t>Stage Storyline (measured in rehearsal)</a:t>
+            </a:r>
+          </a:p>
+        </p:txBody>
+      </p:sp>
+      <p:sp>
+        <p:nvSpPr>
+          <p:cNvPr id="8" name="TextBox 7"/>
+          <p:cNvSpPr txBox="1"/>
+          <p:nvPr/>
+        </p:nvSpPr>
+        <p:spPr>
+          <a:xfrm>
+            <a:off x="502920" y="1536192"/>
+            <a:ext cx="5212080" cy="3703320"/>
+          </a:xfrm>
+          <a:prstGeom prst="rect">
+            <a:avLst/>
+          </a:prstGeom>
+          <a:noFill/>
+        </p:spPr>
+        <p:txBody>
+          <a:bodyPr wrap="square" anchor="t" lIns="73152" rIns="73152" tIns="36576" bIns="36576">
+            <a:spAutoFit/>
+          </a:bodyPr>
+          <a:lstStyle/>
+          <a:p>
+            <a:pPr algn="l">
+              <a:lnSpc>
+                <a:spcPct val="105000"/>
+              </a:lnSpc>
+              <a:spcAft>
+                <a:spcPts val="200"/>
+              </a:spcAft>
+            </a:pPr>
+            <a:r>
+              <a:rPr sz="1100" b="0">
+                <a:solidFill>
+                  <a:srgbClr val="EEF2F8"/>
+                </a:solidFill>
+                <a:latin typeface="Calibri"/>
+              </a:rPr>
+              <a:t>• 0:00 — Train the models live (~4 seconds, deterministic seed)</a:t>
+            </a:r>
+          </a:p>
+          <a:p>
+            <a:pPr algn="l">
+              <a:lnSpc>
+                <a:spcPct val="105000"/>
+              </a:lnSpc>
+              <a:spcAft>
+                <a:spcPts val="200"/>
+              </a:spcAft>
+            </a:pPr>
+            <a:r>
+              <a:rPr sz="1100" b="0">
+                <a:solidFill>
+                  <a:srgbClr val="EEF2F8"/>
+                </a:solidFill>
+                <a:latin typeface="Calibri"/>
+              </a:rPr>
+              <a:t>• 0:10 — Press Start: benign chatter begins</a:t>
+            </a:r>
+          </a:p>
+          <a:p>
+            <a:pPr algn="l">
+              <a:lnSpc>
+                <a:spcPct val="105000"/>
+              </a:lnSpc>
+              <a:spcAft>
+                <a:spcPts val="200"/>
+              </a:spcAft>
+            </a:pPr>
+            <a:r>
+              <a:rPr sz="1100" b="0">
+                <a:solidFill>
+                  <a:srgbClr val="EEF2F8"/>
+                </a:solidFill>
+                <a:latin typeface="Calibri"/>
+              </a:rPr>
+              <a:t>• 0:30 — Quiet window: P(infiltration) = 0.12, no false alarms</a:t>
+            </a:r>
+          </a:p>
+          <a:p>
+            <a:pPr algn="l">
+              <a:lnSpc>
+                <a:spcPct val="105000"/>
+              </a:lnSpc>
+              <a:spcAft>
+                <a:spcPts val="200"/>
+              </a:spcAft>
+            </a:pPr>
+            <a:r>
+              <a:rPr sz="1100" b="0">
+                <a:solidFill>
+                  <a:srgbClr val="EEF2F8"/>
+                </a:solidFill>
+                <a:latin typeface="Calibri"/>
+              </a:rPr>
+              <a:t>• 0:33 — ALERT: scan burst detected at P = 0.97</a:t>
+            </a:r>
+          </a:p>
+          <a:p>
+            <a:pPr algn="l">
+              <a:lnSpc>
+                <a:spcPct val="105000"/>
+              </a:lnSpc>
+              <a:spcAft>
+                <a:spcPts val="200"/>
+              </a:spcAft>
+            </a:pPr>
+            <a:r>
+              <a:rPr sz="1100" b="0">
+                <a:solidFill>
+                  <a:srgbClr val="EEF2F8"/>
+                </a:solidFill>
+                <a:latin typeface="Calibri"/>
+              </a:rPr>
+              <a:t>•          Stage: Initial Access — MITRE ATT&amp;CK TA0001</a:t>
+            </a:r>
+          </a:p>
+          <a:p>
+            <a:pPr algn="l">
+              <a:lnSpc>
+                <a:spcPct val="105000"/>
+              </a:lnSpc>
+              <a:spcAft>
+                <a:spcPts val="200"/>
+              </a:spcAft>
+            </a:pPr>
+            <a:r>
+              <a:rPr sz="1100" b="0">
+                <a:solidFill>
+                  <a:srgbClr val="EEF2F8"/>
+                </a:solidFill>
+                <a:latin typeface="Calibri"/>
+              </a:rPr>
+              <a:t>• 0:48 — Failed logins: P = 1.00, evidence panel grows</a:t>
+            </a:r>
+          </a:p>
+          <a:p>
+            <a:pPr algn="l">
+              <a:lnSpc>
+                <a:spcPct val="105000"/>
+              </a:lnSpc>
+              <a:spcAft>
+                <a:spcPts val="200"/>
+              </a:spcAft>
+            </a:pPr>
+            <a:r>
+              <a:rPr sz="1100" b="0">
+                <a:solidFill>
+                  <a:srgbClr val="EEF2F8"/>
+                </a:solidFill>
+                <a:latin typeface="Calibri"/>
+              </a:rPr>
+              <a:t>• 1:03 — ESCALATION: Lateral Movement — MITRE TA0008</a:t>
+            </a:r>
+          </a:p>
+          <a:p>
+            <a:pPr algn="l">
+              <a:lnSpc>
+                <a:spcPct val="105000"/>
+              </a:lnSpc>
+              <a:spcAft>
+                <a:spcPts val="200"/>
+              </a:spcAft>
+            </a:pPr>
+            <a:r>
+              <a:rPr sz="1100" b="0">
+                <a:solidFill>
+                  <a:srgbClr val="EEF2F8"/>
+                </a:solidFill>
+                <a:latin typeface="Calibri"/>
+              </a:rPr>
+              <a:t>• Same trained artifacts as the offline benchmark</a:t>
+            </a:r>
+          </a:p>
+          <a:p>
+            <a:pPr algn="l">
+              <a:lnSpc>
+                <a:spcPct val="105000"/>
+              </a:lnSpc>
+              <a:spcAft>
+                <a:spcPts val="200"/>
+              </a:spcAft>
+            </a:pPr>
+            <a:r>
+              <a:rPr sz="1100" b="0">
+                <a:solidFill>
+                  <a:srgbClr val="EEF2F8"/>
+                </a:solidFill>
+                <a:latin typeface="Calibri"/>
+              </a:rPr>
+              <a:t>• Sources: demo attack, CIC-IDS2017 replay, live capture</a:t>
+            </a:r>
+          </a:p>
+        </p:txBody>
+      </p:sp>
+      <p:pic>
+        <p:nvPicPr>
+          <p:cNvPr id="9" name="Picture 8" descr="frame_0_t0s.png"/>
+          <p:cNvPicPr>
+            <a:picLocks noChangeAspect="1"/>
+          </p:cNvPicPr>
+          <p:nvPr/>
+        </p:nvPicPr>
+        <p:blipFill>
+          <a:blip r:embed="rId2"/>
+          <a:stretch>
+            <a:fillRect/>
+          </a:stretch>
+        </p:blipFill>
+        <p:spPr>
+          <a:xfrm>
+            <a:off x="5989320" y="1143000"/>
+            <a:ext cx="2377440" cy="1337310"/>
+          </a:xfrm>
+          <a:prstGeom prst="rect">
+            <a:avLst/>
+          </a:prstGeom>
+        </p:spPr>
+      </p:pic>
+      <p:sp>
+        <p:nvSpPr>
+          <p:cNvPr id="10" name="TextBox 9"/>
+          <p:cNvSpPr txBox="1"/>
+          <p:nvPr/>
+        </p:nvSpPr>
+        <p:spPr>
+          <a:xfrm>
+            <a:off x="8458200" y="1645920"/>
+            <a:ext cx="3291840" cy="365760"/>
+          </a:xfrm>
+          <a:prstGeom prst="rect">
+            <a:avLst/>
+          </a:prstGeom>
+          <a:noFill/>
+        </p:spPr>
+        <p:txBody>
+          <a:bodyPr wrap="square" anchor="t" lIns="73152" rIns="73152" tIns="36576" bIns="36576">
+            <a:spAutoFit/>
+          </a:bodyPr>
+          <a:lstStyle/>
+          <a:p>
+            <a:pPr algn="l">
+              <a:lnSpc>
+                <a:spcPct val="105000"/>
+              </a:lnSpc>
+              <a:spcAft>
+                <a:spcPts val="200"/>
+              </a:spcAft>
+            </a:pPr>
+            <a:r>
+              <a:rPr sz="1000" b="0">
+                <a:solidFill>
+                  <a:srgbClr val="2ED3B7"/>
+                </a:solidFill>
+                <a:latin typeface="Calibri"/>
+              </a:rPr>
+              <a:t>t=0 — benign, P=0.12</a:t>
+            </a:r>
+          </a:p>
+        </p:txBody>
+      </p:sp>
+      <p:pic>
+        <p:nvPicPr>
+          <p:cNvPr id="11" name="Picture 10" descr="frame_1_t33s.png"/>
+          <p:cNvPicPr>
+            <a:picLocks noChangeAspect="1"/>
+          </p:cNvPicPr>
+          <p:nvPr/>
+        </p:nvPicPr>
+        <p:blipFill>
+          <a:blip r:embed="rId3"/>
+          <a:stretch>
+            <a:fillRect/>
+          </a:stretch>
+        </p:blipFill>
+        <p:spPr>
+          <a:xfrm>
+            <a:off x="5989320" y="2560320"/>
+            <a:ext cx="2377440" cy="1337310"/>
+          </a:xfrm>
+          <a:prstGeom prst="rect">
+            <a:avLst/>
+          </a:prstGeom>
+        </p:spPr>
+      </p:pic>
+      <p:sp>
+        <p:nvSpPr>
+          <p:cNvPr id="12" name="TextBox 11"/>
+          <p:cNvSpPr txBox="1"/>
+          <p:nvPr/>
+        </p:nvSpPr>
+        <p:spPr>
+          <a:xfrm>
+            <a:off x="8458200" y="3063240"/>
+            <a:ext cx="3291840" cy="365760"/>
+          </a:xfrm>
+          <a:prstGeom prst="rect">
+            <a:avLst/>
+          </a:prstGeom>
+          <a:noFill/>
+        </p:spPr>
+        <p:txBody>
+          <a:bodyPr wrap="square" anchor="t" lIns="73152" rIns="73152" tIns="36576" bIns="36576">
+            <a:spAutoFit/>
+          </a:bodyPr>
+          <a:lstStyle/>
+          <a:p>
+            <a:pPr algn="l">
+              <a:lnSpc>
+                <a:spcPct val="105000"/>
+              </a:lnSpc>
+              <a:spcAft>
+                <a:spcPts val="200"/>
+              </a:spcAft>
+            </a:pPr>
+            <a:r>
+              <a:rPr sz="1000" b="0">
+                <a:solidFill>
+                  <a:srgbClr val="2ED3B7"/>
+                </a:solidFill>
+                <a:latin typeface="Calibri"/>
+              </a:rPr>
+              <a:t>t=33s — ALERT, P=0.97</a:t>
+            </a:r>
+          </a:p>
+        </p:txBody>
+      </p:sp>
+      <p:pic>
+        <p:nvPicPr>
+          <p:cNvPr id="13" name="Picture 12" descr="frame_3_t63s.png"/>
+          <p:cNvPicPr>
+            <a:picLocks noChangeAspect="1"/>
+          </p:cNvPicPr>
+          <p:nvPr/>
+        </p:nvPicPr>
+        <p:blipFill>
+          <a:blip r:embed="rId4"/>
+          <a:stretch>
+            <a:fillRect/>
+          </a:stretch>
+        </p:blipFill>
+        <p:spPr>
+          <a:xfrm>
+            <a:off x="5989320" y="3977639"/>
+            <a:ext cx="2377440" cy="1337310"/>
+          </a:xfrm>
+          <a:prstGeom prst="rect">
+            <a:avLst/>
+          </a:prstGeom>
+        </p:spPr>
+      </p:pic>
+      <p:sp>
+        <p:nvSpPr>
+          <p:cNvPr id="14" name="TextBox 13"/>
+          <p:cNvSpPr txBox="1"/>
+          <p:nvPr/>
+        </p:nvSpPr>
+        <p:spPr>
+          <a:xfrm>
+            <a:off x="8458200" y="4480559"/>
+            <a:ext cx="3291840" cy="365760"/>
+          </a:xfrm>
+          <a:prstGeom prst="rect">
+            <a:avLst/>
+          </a:prstGeom>
+          <a:noFill/>
+        </p:spPr>
+        <p:txBody>
+          <a:bodyPr wrap="square" anchor="t" lIns="73152" rIns="73152" tIns="36576" bIns="36576">
+            <a:spAutoFit/>
+          </a:bodyPr>
+          <a:lstStyle/>
+          <a:p>
+            <a:pPr algn="l">
+              <a:lnSpc>
+                <a:spcPct val="105000"/>
+              </a:lnSpc>
+              <a:spcAft>
+                <a:spcPts val="200"/>
+              </a:spcAft>
+            </a:pPr>
+            <a:r>
+              <a:rPr sz="1000" b="0">
+                <a:solidFill>
+                  <a:srgbClr val="2ED3B7"/>
+                </a:solidFill>
+                <a:latin typeface="Calibri"/>
+              </a:rPr>
+              <a:t>t=63s — Lateral Movement</a:t>
+            </a:r>
+          </a:p>
+        </p:txBody>
+      </p:sp>
+      <p:sp>
+        <p:nvSpPr>
+          <p:cNvPr id="15" name="TextBox 14"/>
+          <p:cNvSpPr txBox="1"/>
+          <p:nvPr/>
+        </p:nvSpPr>
+        <p:spPr>
+          <a:xfrm>
+            <a:off x="411480" y="6492240"/>
+            <a:ext cx="11368735" cy="274320"/>
+          </a:xfrm>
+          <a:prstGeom prst="rect">
+            <a:avLst/>
+          </a:prstGeom>
+          <a:noFill/>
+        </p:spPr>
+        <p:txBody>
+          <a:bodyPr wrap="square" anchor="t" lIns="73152" rIns="73152" tIns="36576" bIns="36576">
+            <a:spAutoFit/>
+          </a:bodyPr>
+          <a:lstStyle/>
+          <a:p>
+            <a:pPr algn="l">
+              <a:lnSpc>
+                <a:spcPct val="105000"/>
+              </a:lnSpc>
+              <a:spcAft>
+                <a:spcPts val="200"/>
+              </a:spcAft>
+            </a:pPr>
+            <a:r>
+              <a:rPr sz="900" b="0">
+                <a:solidFill>
+                  <a:srgbClr val="9FACC2"/>
+                </a:solidFill>
+                <a:latin typeface="Calibri"/>
+              </a:rPr>
+              <a:t>Backup if live infra fails: deliverables/backup_demo/backup_demo.gif (animated) — same numbers as the live run.</a:t>
+            </a:r>
+          </a:p>
+        </p:txBody>
+      </p:sp>
+    </p:spTree>
+  </p:cSld>
+  <p:clrMapOvr>
+    <a:masterClrMapping/>
+  </p:clrMapOvr>
+</p:sld>
+</file>
+
 <file path=ppt/theme/theme1.xml><?xml version="1.0" encoding="utf-8"?>
 <a:theme xmlns:a="http://schemas.openxmlformats.org/drawingml/2006/main" name="Office Theme">
   <a:themeElements>

</xml_diff>

<commit_message>
Update deck slide 7 and backup demo with measured rehearsal timings
Numbers now come from the fresh rehearsal run (reports/generated/rehearsal.json):
alert at 0:34 at P=0.99, escalation at 1:04, benign window at 0:19. Regenerated
the backup frames and GIF so the backup can never contradict the live demo.
</commit_message>
<xml_diff>
--- a/deliverables/Trajectory_SIH26153_Idea_Deck.pptx
+++ b/deliverables/Trajectory_SIH26153_Idea_Deck.pptx
@@ -15652,7 +15652,7 @@
                 </a:solidFill>
                 <a:latin typeface="Calibri"/>
               </a:rPr>
-              <a:t>• 0:00 — Train the models live (~4 seconds, deterministic seed)</a:t>
+              <a:t>• 0:00 — Train the models live (~3 seconds, deterministic seed)</a:t>
             </a:r>
           </a:p>
           <a:p>
@@ -15690,7 +15690,7 @@
                 </a:solidFill>
                 <a:latin typeface="Calibri"/>
               </a:rPr>
-              <a:t>• 0:30 — Quiet window: P(infiltration) = 0.12, no false alarms</a:t>
+              <a:t>• 0:19 — Quiet window: P(infiltration) = 0.12, no false alarms</a:t>
             </a:r>
           </a:p>
           <a:p>
@@ -15709,7 +15709,7 @@
                 </a:solidFill>
                 <a:latin typeface="Calibri"/>
               </a:rPr>
-              <a:t>• 0:33 — ALERT: scan burst detected at P = 0.97</a:t>
+              <a:t>• 0:34 — ALERT: scan burst detected at P = 0.99</a:t>
             </a:r>
           </a:p>
           <a:p>
@@ -15747,7 +15747,7 @@
                 </a:solidFill>
                 <a:latin typeface="Calibri"/>
               </a:rPr>
-              <a:t>• 0:48 — Failed logins: P = 1.00, evidence panel grows</a:t>
+              <a:t>• 0:49 — Failed logins: P = 1.00, evidence panel grows</a:t>
             </a:r>
           </a:p>
           <a:p>
@@ -15766,7 +15766,7 @@
                 </a:solidFill>
                 <a:latin typeface="Calibri"/>
               </a:rPr>
-              <a:t>• 1:03 — ESCALATION: Lateral Movement — MITRE TA0008</a:t>
+              <a:t>• 1:04 — ESCALATION: Lateral Movement — MITRE TA0008</a:t>
             </a:r>
           </a:p>
           <a:p>
@@ -15811,7 +15811,7 @@
       </p:sp>
       <p:pic>
         <p:nvPicPr>
-          <p:cNvPr id="9" name="Picture 8" descr="frame_0_t0s.png"/>
+          <p:cNvPr id="9" name="Picture 8" descr="frame_0_t19s.png"/>
           <p:cNvPicPr>
             <a:picLocks noChangeAspect="1"/>
           </p:cNvPicPr>
@@ -15870,14 +15870,14 @@
                 </a:solidFill>
                 <a:latin typeface="Calibri"/>
               </a:rPr>
-              <a:t>t=0 — benign, P=0.12</a:t>
+              <a:t>t=19s — benign, P=0.12</a:t>
             </a:r>
           </a:p>
         </p:txBody>
       </p:sp>
       <p:pic>
         <p:nvPicPr>
-          <p:cNvPr id="11" name="Picture 10" descr="frame_1_t33s.png"/>
+          <p:cNvPr id="11" name="Picture 10" descr="frame_1_t34s.png"/>
           <p:cNvPicPr>
             <a:picLocks noChangeAspect="1"/>
           </p:cNvPicPr>
@@ -15936,14 +15936,14 @@
                 </a:solidFill>
                 <a:latin typeface="Calibri"/>
               </a:rPr>
-              <a:t>t=33s — ALERT, P=0.97</a:t>
+              <a:t>t=34s — ALERT, P=0.99</a:t>
             </a:r>
           </a:p>
         </p:txBody>
       </p:sp>
       <p:pic>
         <p:nvPicPr>
-          <p:cNvPr id="13" name="Picture 12" descr="frame_3_t63s.png"/>
+          <p:cNvPr id="13" name="Picture 12" descr="frame_3_t64s.png"/>
           <p:cNvPicPr>
             <a:picLocks noChangeAspect="1"/>
           </p:cNvPicPr>
@@ -16002,7 +16002,7 @@
                 </a:solidFill>
                 <a:latin typeface="Calibri"/>
               </a:rPr>
-              <a:t>t=63s — Lateral Movement</a:t>
+              <a:t>t=64s — Lateral Movement</a:t>
             </a:r>
           </a:p>
         </p:txBody>

</xml_diff>